<commit_message>
update wis2-gdc materials for day 3
</commit_message>
<xml_diff>
--- a/Bali-workshop-MAR2026/presentations/day3/wis2-gdc-deep-dive-2026-04-01.pptx
+++ b/Bali-workshop-MAR2026/presentations/day3/wis2-gdc-deep-dive-2026-04-01.pptx
@@ -27574,7 +27574,7 @@
                   <a:schemeClr val="bg1"/>
                 </a:solidFill>
               </a:rPr>
-              <a:t>wis2-gdc: the GDC RI</a:t>
+              <a:t>wis2-gdc exercise</a:t>
             </a:r>
           </a:p>
         </p:txBody>
@@ -27736,67 +27736,6 @@
           <a:lstStyle/>
           <a:p>
             <a:endParaRPr lang="en-CH"/>
-          </a:p>
-        </p:txBody>
-      </p:sp>
-      <p:sp>
-        <p:nvSpPr>
-          <p:cNvPr id="5" name="TextBox 4">
-            <a:extLst>
-              <a:ext uri="{FF2B5EF4-FFF2-40B4-BE49-F238E27FC236}">
-                <a16:creationId xmlns:a16="http://schemas.microsoft.com/office/drawing/2014/main" id="{0F25C77A-E0DE-7213-1B5E-F253BCA0023D}"/>
-              </a:ext>
-            </a:extLst>
-          </p:cNvPr>
-          <p:cNvSpPr txBox="1"/>
-          <p:nvPr/>
-        </p:nvSpPr>
-        <p:spPr>
-          <a:xfrm>
-            <a:off x="8066780" y="6511418"/>
-            <a:ext cx="4336444" cy="246221"/>
-          </a:xfrm>
-          <a:prstGeom prst="rect">
-            <a:avLst/>
-          </a:prstGeom>
-          <a:noFill/>
-        </p:spPr>
-        <p:txBody>
-          <a:bodyPr wrap="none" rtlCol="0">
-            <a:spAutoFit/>
-          </a:bodyPr>
-          <a:lstStyle/>
-          <a:p>
-            <a:r>
-              <a:rPr lang="en-GB" sz="1000" baseline="30000" dirty="0"/>
-              <a:t>1</a:t>
-            </a:r>
-            <a:r>
-              <a:rPr lang="en-GB" sz="1000" dirty="0"/>
-              <a:t> Guide to WIS (WMO No. 1061), Vol II, </a:t>
-            </a:r>
-            <a:r>
-              <a:rPr lang="en-GB" sz="1000" b="0" i="0" dirty="0">
-                <a:solidFill>
-                  <a:srgbClr val="1F1F1F"/>
-                </a:solidFill>
-                <a:effectLst/>
-                <a:latin typeface="Google Sans"/>
-              </a:rPr>
-              <a:t>§1.1.4 </a:t>
-            </a:r>
-            <a:r>
-              <a:rPr lang="en-GB" sz="1000" b="0" i="0" dirty="0">
-                <a:solidFill>
-                  <a:srgbClr val="1F1F1F"/>
-                </a:solidFill>
-                <a:effectLst/>
-                <a:latin typeface="Google Sans"/>
-                <a:hlinkClick r:id="rId3"/>
-              </a:rPr>
-              <a:t>Why are datasets so important</a:t>
-            </a:r>
-            <a:endParaRPr lang="en-GB" sz="1000" dirty="0"/>
           </a:p>
         </p:txBody>
       </p:sp>

</xml_diff>

<commit_message>
minor updates to steps
</commit_message>
<xml_diff>
--- a/Bali-workshop-MAR2026/presentations/day3/wis2-gdc-deep-dive-2026-04-01.pptx
+++ b/Bali-workshop-MAR2026/presentations/day3/wis2-gdc-deep-dive-2026-04-01.pptx
@@ -36678,20 +36678,20 @@
 </file>
 
 <file path=customXml/item1.xml><?xml version="1.0" encoding="utf-8"?>
-<p:properties xmlns:p="http://schemas.microsoft.com/office/2006/metadata/properties" xmlns:xsi="http://www.w3.org/2001/XMLSchema-instance" xmlns:pc="http://schemas.microsoft.com/office/infopath/2007/PartnerControls">
-  <documentManagement>
-    <_activity xmlns="07df4b02-2634-4913-b2a1-f788f994a0fa" xsi:nil="true"/>
-  </documentManagement>
-</p:properties>
-</file>
-
-<file path=customXml/item2.xml><?xml version="1.0" encoding="utf-8"?>
 <?mso-contentType ?>
 <FormTemplates xmlns="http://schemas.microsoft.com/sharepoint/v3/contenttype/forms">
   <Display>DocumentLibraryForm</Display>
   <Edit>DocumentLibraryForm</Edit>
   <New>DocumentLibraryForm</New>
 </FormTemplates>
+</file>
+
+<file path=customXml/item2.xml><?xml version="1.0" encoding="utf-8"?>
+<p:properties xmlns:p="http://schemas.microsoft.com/office/2006/metadata/properties" xmlns:xsi="http://www.w3.org/2001/XMLSchema-instance" xmlns:pc="http://schemas.microsoft.com/office/infopath/2007/PartnerControls">
+  <documentManagement>
+    <_activity xmlns="07df4b02-2634-4913-b2a1-f788f994a0fa" xsi:nil="true"/>
+  </documentManagement>
+</p:properties>
 </file>
 
 <file path=customXml/item3.xml><?xml version="1.0" encoding="utf-8"?>
@@ -36942,6 +36942,14 @@
 </file>
 
 <file path=customXml/itemProps1.xml><?xml version="1.0" encoding="utf-8"?>
+<ds:datastoreItem xmlns:ds="http://schemas.openxmlformats.org/officeDocument/2006/customXml" ds:itemID="{F727FCF3-D210-4447-9999-135BE84AA52C}">
+  <ds:schemaRefs>
+    <ds:schemaRef ds:uri="http://schemas.microsoft.com/sharepoint/v3/contenttype/forms"/>
+  </ds:schemaRefs>
+</ds:datastoreItem>
+</file>
+
+<file path=customXml/itemProps2.xml><?xml version="1.0" encoding="utf-8"?>
 <ds:datastoreItem xmlns:ds="http://schemas.openxmlformats.org/officeDocument/2006/customXml" ds:itemID="{4FA777BE-1691-46D3-B5EF-D93DCFCAC224}">
   <ds:schemaRefs>
     <ds:schemaRef ds:uri="http://schemas.microsoft.com/office/2006/documentManagement/types"/>
@@ -36954,14 +36962,6 @@
     <ds:schemaRef ds:uri="http://purl.org/dc/dcmitype/"/>
     <ds:schemaRef ds:uri="http://purl.org/dc/terms/"/>
     <ds:schemaRef ds:uri="http://purl.org/dc/elements/1.1/"/>
-  </ds:schemaRefs>
-</ds:datastoreItem>
-</file>
-
-<file path=customXml/itemProps2.xml><?xml version="1.0" encoding="utf-8"?>
-<ds:datastoreItem xmlns:ds="http://schemas.openxmlformats.org/officeDocument/2006/customXml" ds:itemID="{F727FCF3-D210-4447-9999-135BE84AA52C}">
-  <ds:schemaRefs>
-    <ds:schemaRef ds:uri="http://schemas.microsoft.com/sharepoint/v3/contenttype/forms"/>
   </ds:schemaRefs>
 </ds:datastoreItem>
 </file>

</xml_diff>